<commit_message>
chore(tests): regenerate reference docs and extract XML
- Fix multiline string syntax in code_blocks generator
- Regenerate all 8 DOCX files (minimal, styled, headings, tables, lists, code_blocks, images, layout)
- Regenerate all 8 PPTX files (minimal, content, styled, table, image, charts, notes, two_column)
- Extract XML from all 16 reference docs into tests/fixtures/expected_xml/
- Mark unzip and XML extraction tasks complete in TODO
</commit_message>
<xml_diff>
--- a/tests/fixtures/reference_docs/minimal.pptx
+++ b/tests/fixtures/reference_docs/minimal.pptx
@@ -3123,7 +3123,11 @@
         <p:txBody>
           <a:bodyPr/>
           <a:lstStyle/>
-          <a:p/>
+          <a:p>
+            <a:r>
+              <a:t>Subtitle text</a:t>
+            </a:r>
+          </a:p>
         </p:txBody>
       </p:sp>
     </p:spTree>

</xml_diff>